<commit_message>
Added Technical Presentation final touches
</commit_message>
<xml_diff>
--- a/PDE4444_Technical_Presentation.pptx
+++ b/PDE4444_Technical_Presentation.pptx
@@ -2537,14 +2537,17 @@
         </p:nvSpPr>
         <p:spPr>
           <a:xfrm>
-            <a:off x="952500" y="2376646"/>
-            <a:ext cx="5156200" cy="3688080"/>
+            <a:off x="952500" y="2148046"/>
+            <a:ext cx="5232400" cy="2667000"/>
           </a:xfrm>
           <a:prstGeom prst="roundRect">
             <a:avLst>
-              <a:gd name="adj" fmla="val 3099"/>
+              <a:gd name="adj" fmla="val 4286"/>
             </a:avLst>
           </a:prstGeom>
+          <a:solidFill>
+            <a:srgbClr val="090E12"/>
+          </a:solidFill>
           <a:ln w="7620">
             <a:solidFill>
               <a:srgbClr val="212A31"/>
@@ -2553,102 +2556,44 @@
           </a:ln>
         </p:spPr>
       </p:sp>
-      <p:sp>
-        <p:nvSpPr>
-          <p:cNvPr id="5" name="Text 3"/>
-          <p:cNvSpPr/>
-          <p:nvPr/>
-        </p:nvSpPr>
-        <p:spPr>
-          <a:xfrm>
-            <a:off x="1717573" y="3893026"/>
-            <a:ext cx="3626053" cy="342900"/>
-          </a:xfrm>
-          <a:prstGeom prst="rect">
-            <a:avLst/>
-          </a:prstGeom>
-          <a:noFill/>
-          <a:ln/>
-        </p:spPr>
-        <p:txBody>
-          <a:bodyPr wrap="square" lIns="25400" tIns="25400" rIns="25400" bIns="25400" rtlCol="0" anchor="t">
-            <a:normAutofit/>
-          </a:bodyPr>
-          <a:lstStyle/>
-          <a:p>
-            <a:pPr algn="ctr" indent="0" marL="0">
-              <a:buNone/>
-            </a:pPr>
-            <a:r>
-              <a:rPr lang="en-US" sz="2100" dirty="0">
-                <a:solidFill>
-                  <a:srgbClr val="42494E"/>
-                </a:solidFill>
-                <a:latin typeface="Courier New" pitchFamily="34" charset="0"/>
-                <a:ea typeface="Courier New" pitchFamily="34" charset="-122"/>
-                <a:cs typeface="Courier New" pitchFamily="34" charset="-120"/>
-              </a:rPr>
-              <a:t>breadboard_pass_01.jpg</a:t>
-            </a:r>
-            <a:endParaRPr lang="en-US" sz="2100" dirty="0"/>
-          </a:p>
-        </p:txBody>
-      </p:sp>
-      <p:sp>
-        <p:nvSpPr>
-          <p:cNvPr id="6" name="Text 4"/>
-          <p:cNvSpPr/>
-          <p:nvPr/>
-        </p:nvSpPr>
-        <p:spPr>
-          <a:xfrm>
-            <a:off x="1523321" y="4312126"/>
-            <a:ext cx="4014559" cy="274320"/>
-          </a:xfrm>
-          <a:prstGeom prst="rect">
-            <a:avLst/>
-          </a:prstGeom>
-          <a:noFill/>
-          <a:ln/>
-        </p:spPr>
-        <p:txBody>
-          <a:bodyPr wrap="square" lIns="25400" tIns="25400" rIns="25400" bIns="25400" rtlCol="0" anchor="t">
-            <a:normAutofit/>
-          </a:bodyPr>
-          <a:lstStyle/>
-          <a:p>
-            <a:pPr algn="ctr" indent="0" marL="0">
-              <a:buNone/>
-            </a:pPr>
-            <a:r>
-              <a:rPr lang="en-US" sz="1650" dirty="0">
-                <a:solidFill>
-                  <a:srgbClr val="363B3F"/>
-                </a:solidFill>
-                <a:latin typeface="Courier New" pitchFamily="34" charset="0"/>
-                <a:ea typeface="Courier New" pitchFamily="34" charset="-122"/>
-                <a:cs typeface="Courier New" pitchFamily="34" charset="-120"/>
-              </a:rPr>
-              <a:t>overhead camera · unseen sample</a:t>
-            </a:r>
-            <a:endParaRPr lang="en-US" sz="1650" dirty="0"/>
-          </a:p>
-        </p:txBody>
-      </p:sp>
-      <p:sp>
-        <p:nvSpPr>
-          <p:cNvPr id="7" name="Shape 5"/>
-          <p:cNvSpPr/>
-          <p:nvPr/>
-        </p:nvSpPr>
-        <p:spPr>
-          <a:xfrm>
-            <a:off x="952500" y="6255226"/>
-            <a:ext cx="5156200" cy="2621280"/>
+      <p:pic>
+        <p:nvPicPr>
+          <p:cNvPr id="5" name="Image 0" descr="preencoded.png">    </p:cNvPr>
+          <p:cNvPicPr>
+            <a:picLocks noChangeAspect="1"/>
+          </p:cNvPicPr>
+          <p:nvPr/>
+        </p:nvPicPr>
+        <p:blipFill>
+          <a:blip r:embed="rId1"/>
+          <a:stretch>
+            <a:fillRect/>
+          </a:stretch>
+        </p:blipFill>
+        <p:spPr>
+          <a:xfrm>
+            <a:off x="960120" y="2155666"/>
+            <a:ext cx="5217160" cy="2651760"/>
+          </a:xfrm>
+          <a:prstGeom prst="rect">
+            <a:avLst/>
+          </a:prstGeom>
+        </p:spPr>
+      </p:pic>
+      <p:sp>
+        <p:nvSpPr>
+          <p:cNvPr id="6" name="Shape 3"/>
+          <p:cNvSpPr/>
+          <p:nvPr/>
+        </p:nvSpPr>
+        <p:spPr>
+          <a:xfrm>
+            <a:off x="952500" y="4967446"/>
+            <a:ext cx="5232400" cy="1855470"/>
           </a:xfrm>
           <a:prstGeom prst="roundRect">
             <a:avLst>
-              <a:gd name="adj" fmla="val 4360"/>
+              <a:gd name="adj" fmla="val 6160"/>
             </a:avLst>
           </a:prstGeom>
           <a:solidFill>
@@ -2664,14 +2609,14 @@
       </p:sp>
       <p:sp>
         <p:nvSpPr>
-          <p:cNvPr id="8" name="Text 6"/>
-          <p:cNvSpPr/>
-          <p:nvPr/>
-        </p:nvSpPr>
-        <p:spPr>
-          <a:xfrm>
-            <a:off x="1303020" y="6529546"/>
-            <a:ext cx="4588815" cy="297180"/>
+          <p:cNvPr id="7" name="Text 4"/>
+          <p:cNvSpPr/>
+          <p:nvPr/>
+        </p:nvSpPr>
+        <p:spPr>
+          <a:xfrm>
+            <a:off x="1226820" y="5184616"/>
+            <a:ext cx="4824273" cy="297180"/>
           </a:xfrm>
           <a:prstGeom prst="rect">
             <a:avLst/>
@@ -2705,14 +2650,14 @@
       </p:sp>
       <p:sp>
         <p:nvSpPr>
-          <p:cNvPr id="9" name="Text 7"/>
-          <p:cNvSpPr/>
-          <p:nvPr/>
-        </p:nvSpPr>
-        <p:spPr>
-          <a:xfrm>
-            <a:off x="1303020" y="6883876"/>
-            <a:ext cx="4588815" cy="533400"/>
+          <p:cNvPr id="8" name="Text 5"/>
+          <p:cNvSpPr/>
+          <p:nvPr/>
+        </p:nvSpPr>
+        <p:spPr>
+          <a:xfrm>
+            <a:off x="1226820" y="5519896"/>
+            <a:ext cx="4824273" cy="457200"/>
           </a:xfrm>
           <a:prstGeom prst="rect">
             <a:avLst/>
@@ -2733,7 +2678,7 @@
               <a:buNone/>
             </a:pPr>
             <a:r>
-              <a:rPr lang="en-US" sz="3900" b="1" dirty="0">
+              <a:rPr lang="en-US" sz="3300" b="1" dirty="0">
                 <a:solidFill>
                   <a:srgbClr val="00B764"/>
                 </a:solidFill>
@@ -2743,20 +2688,20 @@
               </a:rPr>
               <a:t>PASS</a:t>
             </a:r>
-            <a:endParaRPr lang="en-US" sz="3900" dirty="0"/>
-          </a:p>
-        </p:txBody>
-      </p:sp>
-      <p:sp>
-        <p:nvSpPr>
-          <p:cNvPr id="10" name="Text 8"/>
-          <p:cNvSpPr/>
-          <p:nvPr/>
-        </p:nvSpPr>
-        <p:spPr>
-          <a:xfrm>
-            <a:off x="1303020" y="7474426"/>
-            <a:ext cx="4588815" cy="312420"/>
+            <a:endParaRPr lang="en-US" sz="3300" dirty="0"/>
+          </a:p>
+        </p:txBody>
+      </p:sp>
+      <p:sp>
+        <p:nvSpPr>
+          <p:cNvPr id="9" name="Text 6"/>
+          <p:cNvSpPr/>
+          <p:nvPr/>
+        </p:nvSpPr>
+        <p:spPr>
+          <a:xfrm>
+            <a:off x="1226820" y="6015196"/>
+            <a:ext cx="4824273" cy="312420"/>
           </a:xfrm>
           <a:prstGeom prst="rect">
             <a:avLst/>
@@ -2796,7 +2741,7 @@
                 <a:ea typeface="Arial" pitchFamily="34" charset="-122"/>
                 <a:cs typeface="Arial" pitchFamily="34" charset="-120"/>
               </a:rPr>
-              <a:t>97.3%</a:t>
+              <a:t>98.74%</a:t>
             </a:r>
             <a:endParaRPr lang="en-US" sz="1680" dirty="0"/>
           </a:p>
@@ -2804,14 +2749,14 @@
       </p:sp>
       <p:sp>
         <p:nvSpPr>
-          <p:cNvPr id="11" name="Text 9"/>
-          <p:cNvSpPr/>
-          <p:nvPr/>
-        </p:nvSpPr>
-        <p:spPr>
-          <a:xfrm>
-            <a:off x="1303020" y="7824946"/>
-            <a:ext cx="4588815" cy="815340"/>
+          <p:cNvPr id="10" name="Text 7"/>
+          <p:cNvSpPr/>
+          <p:nvPr/>
+        </p:nvSpPr>
+        <p:spPr>
+          <a:xfrm>
+            <a:off x="1226820" y="6346666"/>
+            <a:ext cx="4824273" cy="297180"/>
           </a:xfrm>
           <a:prstGeom prst="rect">
             <a:avLst/>
@@ -2837,7 +2782,7 @@
                 <a:ea typeface="Arial" pitchFamily="34" charset="-122"/>
                 <a:cs typeface="Arial" pitchFamily="34" charset="-120"/>
               </a:rPr>
-              <a:t>Model correctly identified a valid breadboard circuit with all components correctly seated</a:t>
+              <a:t>All components correctly seated</a:t>
             </a:r>
             <a:endParaRPr lang="en-US" sz="1800" dirty="0"/>
           </a:p>
@@ -2845,20 +2790,23 @@
       </p:sp>
       <p:sp>
         <p:nvSpPr>
-          <p:cNvPr id="12" name="Shape 10"/>
-          <p:cNvSpPr/>
-          <p:nvPr/>
-        </p:nvSpPr>
-        <p:spPr>
-          <a:xfrm>
-            <a:off x="6565900" y="2376646"/>
-            <a:ext cx="5156200" cy="3688080"/>
+          <p:cNvPr id="11" name="Shape 8"/>
+          <p:cNvSpPr/>
+          <p:nvPr/>
+        </p:nvSpPr>
+        <p:spPr>
+          <a:xfrm>
+            <a:off x="6527800" y="2148046"/>
+            <a:ext cx="5232400" cy="2667000"/>
           </a:xfrm>
           <a:prstGeom prst="roundRect">
             <a:avLst>
-              <a:gd name="adj" fmla="val 3099"/>
+              <a:gd name="adj" fmla="val 4286"/>
             </a:avLst>
           </a:prstGeom>
+          <a:solidFill>
+            <a:srgbClr val="090E12"/>
+          </a:solidFill>
           <a:ln w="7620">
             <a:solidFill>
               <a:srgbClr val="212A31"/>
@@ -2867,102 +2815,44 @@
           </a:ln>
         </p:spPr>
       </p:sp>
-      <p:sp>
-        <p:nvSpPr>
-          <p:cNvPr id="13" name="Text 11"/>
-          <p:cNvSpPr/>
-          <p:nvPr/>
-        </p:nvSpPr>
-        <p:spPr>
-          <a:xfrm>
-            <a:off x="7330974" y="3893026"/>
-            <a:ext cx="3626053" cy="342900"/>
-          </a:xfrm>
-          <a:prstGeom prst="rect">
-            <a:avLst/>
-          </a:prstGeom>
-          <a:noFill/>
-          <a:ln/>
-        </p:spPr>
-        <p:txBody>
-          <a:bodyPr wrap="square" lIns="25400" tIns="25400" rIns="25400" bIns="25400" rtlCol="0" anchor="t">
-            <a:normAutofit/>
-          </a:bodyPr>
-          <a:lstStyle/>
-          <a:p>
-            <a:pPr algn="ctr" indent="0" marL="0">
-              <a:buNone/>
-            </a:pPr>
-            <a:r>
-              <a:rPr lang="en-US" sz="2100" dirty="0">
-                <a:solidFill>
-                  <a:srgbClr val="42494E"/>
-                </a:solidFill>
-                <a:latin typeface="Courier New" pitchFamily="34" charset="0"/>
-                <a:ea typeface="Courier New" pitchFamily="34" charset="-122"/>
-                <a:cs typeface="Courier New" pitchFamily="34" charset="-120"/>
-              </a:rPr>
-              <a:t>breadboard_fail_07.jpg</a:t>
-            </a:r>
-            <a:endParaRPr lang="en-US" sz="2100" dirty="0"/>
-          </a:p>
-        </p:txBody>
-      </p:sp>
-      <p:sp>
-        <p:nvSpPr>
-          <p:cNvPr id="14" name="Text 12"/>
-          <p:cNvSpPr/>
-          <p:nvPr/>
-        </p:nvSpPr>
-        <p:spPr>
-          <a:xfrm>
-            <a:off x="7136721" y="4312126"/>
-            <a:ext cx="4014559" cy="274320"/>
-          </a:xfrm>
-          <a:prstGeom prst="rect">
-            <a:avLst/>
-          </a:prstGeom>
-          <a:noFill/>
-          <a:ln/>
-        </p:spPr>
-        <p:txBody>
-          <a:bodyPr wrap="square" lIns="25400" tIns="25400" rIns="25400" bIns="25400" rtlCol="0" anchor="t">
-            <a:normAutofit/>
-          </a:bodyPr>
-          <a:lstStyle/>
-          <a:p>
-            <a:pPr algn="ctr" indent="0" marL="0">
-              <a:buNone/>
-            </a:pPr>
-            <a:r>
-              <a:rPr lang="en-US" sz="1650" dirty="0">
-                <a:solidFill>
-                  <a:srgbClr val="363B3F"/>
-                </a:solidFill>
-                <a:latin typeface="Courier New" pitchFamily="34" charset="0"/>
-                <a:ea typeface="Courier New" pitchFamily="34" charset="-122"/>
-                <a:cs typeface="Courier New" pitchFamily="34" charset="-120"/>
-              </a:rPr>
-              <a:t>overhead camera · unseen sample</a:t>
-            </a:r>
-            <a:endParaRPr lang="en-US" sz="1650" dirty="0"/>
-          </a:p>
-        </p:txBody>
-      </p:sp>
-      <p:sp>
-        <p:nvSpPr>
-          <p:cNvPr id="15" name="Shape 13"/>
-          <p:cNvSpPr/>
-          <p:nvPr/>
-        </p:nvSpPr>
-        <p:spPr>
-          <a:xfrm>
-            <a:off x="6565900" y="6255226"/>
-            <a:ext cx="5156200" cy="2621280"/>
+      <p:pic>
+        <p:nvPicPr>
+          <p:cNvPr id="12" name="Image 1" descr="preencoded.png">    </p:cNvPr>
+          <p:cNvPicPr>
+            <a:picLocks noChangeAspect="1"/>
+          </p:cNvPicPr>
+          <p:nvPr/>
+        </p:nvPicPr>
+        <p:blipFill>
+          <a:blip r:embed="rId2"/>
+          <a:stretch>
+            <a:fillRect/>
+          </a:stretch>
+        </p:blipFill>
+        <p:spPr>
+          <a:xfrm>
+            <a:off x="6535420" y="2155666"/>
+            <a:ext cx="5217160" cy="2651760"/>
+          </a:xfrm>
+          <a:prstGeom prst="rect">
+            <a:avLst/>
+          </a:prstGeom>
+        </p:spPr>
+      </p:pic>
+      <p:sp>
+        <p:nvSpPr>
+          <p:cNvPr id="13" name="Shape 9"/>
+          <p:cNvSpPr/>
+          <p:nvPr/>
+        </p:nvSpPr>
+        <p:spPr>
+          <a:xfrm>
+            <a:off x="6527800" y="4967446"/>
+            <a:ext cx="5232400" cy="2114550"/>
           </a:xfrm>
           <a:prstGeom prst="roundRect">
             <a:avLst>
-              <a:gd name="adj" fmla="val 4360"/>
+              <a:gd name="adj" fmla="val 5405"/>
             </a:avLst>
           </a:prstGeom>
           <a:solidFill>
@@ -2978,14 +2868,14 @@
       </p:sp>
       <p:sp>
         <p:nvSpPr>
-          <p:cNvPr id="16" name="Text 14"/>
-          <p:cNvSpPr/>
-          <p:nvPr/>
-        </p:nvSpPr>
-        <p:spPr>
-          <a:xfrm>
-            <a:off x="6916420" y="6529546"/>
-            <a:ext cx="4588815" cy="297180"/>
+          <p:cNvPr id="14" name="Text 10"/>
+          <p:cNvSpPr/>
+          <p:nvPr/>
+        </p:nvSpPr>
+        <p:spPr>
+          <a:xfrm>
+            <a:off x="6802120" y="5184616"/>
+            <a:ext cx="4824273" cy="297180"/>
           </a:xfrm>
           <a:prstGeom prst="rect">
             <a:avLst/>
@@ -3019,14 +2909,14 @@
       </p:sp>
       <p:sp>
         <p:nvSpPr>
-          <p:cNvPr id="17" name="Text 15"/>
-          <p:cNvSpPr/>
-          <p:nvPr/>
-        </p:nvSpPr>
-        <p:spPr>
-          <a:xfrm>
-            <a:off x="6916420" y="6883876"/>
-            <a:ext cx="4588815" cy="533400"/>
+          <p:cNvPr id="15" name="Text 11"/>
+          <p:cNvSpPr/>
+          <p:nvPr/>
+        </p:nvSpPr>
+        <p:spPr>
+          <a:xfrm>
+            <a:off x="6802120" y="5519896"/>
+            <a:ext cx="4824273" cy="457200"/>
           </a:xfrm>
           <a:prstGeom prst="rect">
             <a:avLst/>
@@ -3047,7 +2937,7 @@
               <a:buNone/>
             </a:pPr>
             <a:r>
-              <a:rPr lang="en-US" sz="3900" b="1" dirty="0">
+              <a:rPr lang="en-US" sz="3300" b="1" dirty="0">
                 <a:solidFill>
                   <a:srgbClr val="E64343"/>
                 </a:solidFill>
@@ -3057,20 +2947,20 @@
               </a:rPr>
               <a:t>FAIL</a:t>
             </a:r>
-            <a:endParaRPr lang="en-US" sz="3900" dirty="0"/>
-          </a:p>
-        </p:txBody>
-      </p:sp>
-      <p:sp>
-        <p:nvSpPr>
-          <p:cNvPr id="18" name="Text 16"/>
-          <p:cNvSpPr/>
-          <p:nvPr/>
-        </p:nvSpPr>
-        <p:spPr>
-          <a:xfrm>
-            <a:off x="6916420" y="7474426"/>
-            <a:ext cx="4588815" cy="312420"/>
+            <a:endParaRPr lang="en-US" sz="3300" dirty="0"/>
+          </a:p>
+        </p:txBody>
+      </p:sp>
+      <p:sp>
+        <p:nvSpPr>
+          <p:cNvPr id="16" name="Text 12"/>
+          <p:cNvSpPr/>
+          <p:nvPr/>
+        </p:nvSpPr>
+        <p:spPr>
+          <a:xfrm>
+            <a:off x="6802120" y="6015196"/>
+            <a:ext cx="4824273" cy="312420"/>
           </a:xfrm>
           <a:prstGeom prst="rect">
             <a:avLst/>
@@ -3110,7 +3000,7 @@
                 <a:ea typeface="Arial" pitchFamily="34" charset="-122"/>
                 <a:cs typeface="Arial" pitchFamily="34" charset="-120"/>
               </a:rPr>
-              <a:t>91.8%</a:t>
+              <a:t>99.99%</a:t>
             </a:r>
             <a:endParaRPr lang="en-US" sz="1680" dirty="0"/>
           </a:p>
@@ -3118,14 +3008,14 @@
       </p:sp>
       <p:sp>
         <p:nvSpPr>
-          <p:cNvPr id="19" name="Text 17"/>
-          <p:cNvSpPr/>
-          <p:nvPr/>
-        </p:nvSpPr>
-        <p:spPr>
-          <a:xfrm>
-            <a:off x="6916420" y="7824946"/>
-            <a:ext cx="4588815" cy="815340"/>
+          <p:cNvPr id="17" name="Text 13"/>
+          <p:cNvSpPr/>
+          <p:nvPr/>
+        </p:nvSpPr>
+        <p:spPr>
+          <a:xfrm>
+            <a:off x="6802120" y="6346666"/>
+            <a:ext cx="4824273" cy="556260"/>
           </a:xfrm>
           <a:prstGeom prst="rect">
             <a:avLst/>
@@ -3151,7 +3041,7 @@
                 <a:ea typeface="Arial" pitchFamily="34" charset="-122"/>
                 <a:cs typeface="Arial" pitchFamily="34" charset="-120"/>
               </a:rPr>
-              <a:t>Model correctly flagged a defective circuit — moved component detected via learned feature maps</a:t>
+              <a:t>Moved component detected via learned feature maps</a:t>
             </a:r>
             <a:endParaRPr lang="en-US" sz="1800" dirty="0"/>
           </a:p>
@@ -3159,20 +3049,23 @@
       </p:sp>
       <p:sp>
         <p:nvSpPr>
-          <p:cNvPr id="20" name="Shape 18"/>
-          <p:cNvSpPr/>
-          <p:nvPr/>
-        </p:nvSpPr>
-        <p:spPr>
-          <a:xfrm>
-            <a:off x="12179300" y="2376646"/>
-            <a:ext cx="5156200" cy="3429000"/>
+          <p:cNvPr id="18" name="Shape 14"/>
+          <p:cNvSpPr/>
+          <p:nvPr/>
+        </p:nvSpPr>
+        <p:spPr>
+          <a:xfrm>
+            <a:off x="12103100" y="2148046"/>
+            <a:ext cx="5232400" cy="2667000"/>
           </a:xfrm>
           <a:prstGeom prst="roundRect">
             <a:avLst>
-              <a:gd name="adj" fmla="val 3333"/>
+              <a:gd name="adj" fmla="val 4286"/>
             </a:avLst>
           </a:prstGeom>
+          <a:solidFill>
+            <a:srgbClr val="090E12"/>
+          </a:solidFill>
           <a:ln w="7620">
             <a:solidFill>
               <a:srgbClr val="212A31"/>
@@ -3181,102 +3074,44 @@
           </a:ln>
         </p:spPr>
       </p:sp>
-      <p:sp>
-        <p:nvSpPr>
-          <p:cNvPr id="21" name="Text 19"/>
-          <p:cNvSpPr/>
-          <p:nvPr/>
-        </p:nvSpPr>
-        <p:spPr>
-          <a:xfrm>
-            <a:off x="12944373" y="3763486"/>
-            <a:ext cx="3626053" cy="342900"/>
-          </a:xfrm>
-          <a:prstGeom prst="rect">
-            <a:avLst/>
-          </a:prstGeom>
-          <a:noFill/>
-          <a:ln/>
-        </p:spPr>
-        <p:txBody>
-          <a:bodyPr wrap="square" lIns="25400" tIns="25400" rIns="25400" bIns="25400" rtlCol="0" anchor="t">
-            <a:normAutofit/>
-          </a:bodyPr>
-          <a:lstStyle/>
-          <a:p>
-            <a:pPr algn="ctr" indent="0" marL="0">
-              <a:buNone/>
-            </a:pPr>
-            <a:r>
-              <a:rPr lang="en-US" sz="2100" dirty="0">
-                <a:solidFill>
-                  <a:srgbClr val="42494E"/>
-                </a:solidFill>
-                <a:latin typeface="Courier New" pitchFamily="34" charset="0"/>
-                <a:ea typeface="Courier New" pitchFamily="34" charset="-122"/>
-                <a:cs typeface="Courier New" pitchFamily="34" charset="-120"/>
-              </a:rPr>
-              <a:t>breadboard_pass_12.jpg</a:t>
-            </a:r>
-            <a:endParaRPr lang="en-US" sz="2100" dirty="0"/>
-          </a:p>
-        </p:txBody>
-      </p:sp>
-      <p:sp>
-        <p:nvSpPr>
-          <p:cNvPr id="22" name="Text 20"/>
-          <p:cNvSpPr/>
-          <p:nvPr/>
-        </p:nvSpPr>
-        <p:spPr>
-          <a:xfrm>
-            <a:off x="12750121" y="4182586"/>
-            <a:ext cx="4014559" cy="274320"/>
-          </a:xfrm>
-          <a:prstGeom prst="rect">
-            <a:avLst/>
-          </a:prstGeom>
-          <a:noFill/>
-          <a:ln/>
-        </p:spPr>
-        <p:txBody>
-          <a:bodyPr wrap="square" lIns="25400" tIns="25400" rIns="25400" bIns="25400" rtlCol="0" anchor="t">
-            <a:normAutofit/>
-          </a:bodyPr>
-          <a:lstStyle/>
-          <a:p>
-            <a:pPr algn="ctr" indent="0" marL="0">
-              <a:buNone/>
-            </a:pPr>
-            <a:r>
-              <a:rPr lang="en-US" sz="1650" dirty="0">
-                <a:solidFill>
-                  <a:srgbClr val="363B3F"/>
-                </a:solidFill>
-                <a:latin typeface="Courier New" pitchFamily="34" charset="0"/>
-                <a:ea typeface="Courier New" pitchFamily="34" charset="-122"/>
-                <a:cs typeface="Courier New" pitchFamily="34" charset="-120"/>
-              </a:rPr>
-              <a:t>overhead camera · unseen sample</a:t>
-            </a:r>
-            <a:endParaRPr lang="en-US" sz="1650" dirty="0"/>
-          </a:p>
-        </p:txBody>
-      </p:sp>
-      <p:sp>
-        <p:nvSpPr>
-          <p:cNvPr id="23" name="Shape 21"/>
-          <p:cNvSpPr/>
-          <p:nvPr/>
-        </p:nvSpPr>
-        <p:spPr>
-          <a:xfrm>
-            <a:off x="12179300" y="5996146"/>
-            <a:ext cx="5156200" cy="2880360"/>
+      <p:pic>
+        <p:nvPicPr>
+          <p:cNvPr id="19" name="Image 2" descr="preencoded.png">    </p:cNvPr>
+          <p:cNvPicPr>
+            <a:picLocks noChangeAspect="1"/>
+          </p:cNvPicPr>
+          <p:nvPr/>
+        </p:nvPicPr>
+        <p:blipFill>
+          <a:blip r:embed="rId3"/>
+          <a:stretch>
+            <a:fillRect/>
+          </a:stretch>
+        </p:blipFill>
+        <p:spPr>
+          <a:xfrm>
+            <a:off x="12110720" y="2155666"/>
+            <a:ext cx="5217160" cy="2651760"/>
+          </a:xfrm>
+          <a:prstGeom prst="rect">
+            <a:avLst/>
+          </a:prstGeom>
+        </p:spPr>
+      </p:pic>
+      <p:sp>
+        <p:nvSpPr>
+          <p:cNvPr id="20" name="Shape 15"/>
+          <p:cNvSpPr/>
+          <p:nvPr/>
+        </p:nvSpPr>
+        <p:spPr>
+          <a:xfrm>
+            <a:off x="12103100" y="4967446"/>
+            <a:ext cx="5232400" cy="2114550"/>
           </a:xfrm>
           <a:prstGeom prst="roundRect">
             <a:avLst>
-              <a:gd name="adj" fmla="val 3968"/>
+              <a:gd name="adj" fmla="val 5405"/>
             </a:avLst>
           </a:prstGeom>
           <a:solidFill>
@@ -3292,14 +3127,14 @@
       </p:sp>
       <p:sp>
         <p:nvSpPr>
-          <p:cNvPr id="24" name="Text 22"/>
-          <p:cNvSpPr/>
-          <p:nvPr/>
-        </p:nvSpPr>
-        <p:spPr>
-          <a:xfrm>
-            <a:off x="12529820" y="6270466"/>
-            <a:ext cx="4588815" cy="556260"/>
+          <p:cNvPr id="21" name="Text 16"/>
+          <p:cNvSpPr/>
+          <p:nvPr/>
+        </p:nvSpPr>
+        <p:spPr>
+          <a:xfrm>
+            <a:off x="12377420" y="5184616"/>
+            <a:ext cx="4824273" cy="297180"/>
           </a:xfrm>
           <a:prstGeom prst="rect">
             <a:avLst/>
@@ -3333,14 +3168,14 @@
       </p:sp>
       <p:sp>
         <p:nvSpPr>
-          <p:cNvPr id="25" name="Text 23"/>
-          <p:cNvSpPr/>
-          <p:nvPr/>
-        </p:nvSpPr>
-        <p:spPr>
-          <a:xfrm>
-            <a:off x="12529820" y="6883876"/>
-            <a:ext cx="1263015" cy="533400"/>
+          <p:cNvPr id="22" name="Text 17"/>
+          <p:cNvSpPr/>
+          <p:nvPr/>
+        </p:nvSpPr>
+        <p:spPr>
+          <a:xfrm>
+            <a:off x="12377420" y="5519896"/>
+            <a:ext cx="1080453" cy="457200"/>
           </a:xfrm>
           <a:prstGeom prst="rect">
             <a:avLst/>
@@ -3361,7 +3196,7 @@
               <a:buNone/>
             </a:pPr>
             <a:r>
-              <a:rPr lang="en-US" sz="3900" b="1" dirty="0">
+              <a:rPr lang="en-US" sz="3300" b="1" dirty="0">
                 <a:solidFill>
                   <a:srgbClr val="00B764"/>
                 </a:solidFill>
@@ -3371,38 +3206,38 @@
               </a:rPr>
               <a:t>PASS</a:t>
             </a:r>
-            <a:endParaRPr lang="en-US" sz="3900" dirty="0"/>
-          </a:p>
-        </p:txBody>
-      </p:sp>
-      <p:sp>
-        <p:nvSpPr>
-          <p:cNvPr id="26" name="Text 24"/>
-          <p:cNvSpPr/>
-          <p:nvPr/>
-        </p:nvSpPr>
-        <p:spPr>
-          <a:xfrm>
-            <a:off x="13907135" y="6929596"/>
-            <a:ext cx="419100" cy="441960"/>
-          </a:xfrm>
-          <a:prstGeom prst="rect">
-            <a:avLst/>
-          </a:prstGeom>
-          <a:noFill/>
-          <a:ln/>
-        </p:spPr>
-        <p:txBody>
-          <a:bodyPr wrap="square" lIns="25400" tIns="25400" rIns="25400" bIns="25400" rtlCol="0" anchor="t">
-            <a:normAutofit/>
-          </a:bodyPr>
-          <a:lstStyle/>
-          <a:p>
-            <a:pPr algn="l" indent="0" marL="0">
-              <a:buNone/>
-            </a:pPr>
-            <a:r>
-              <a:rPr lang="en-US" sz="2700" dirty="0">
+            <a:endParaRPr lang="en-US" sz="3300" dirty="0"/>
+          </a:p>
+        </p:txBody>
+      </p:sp>
+      <p:sp>
+        <p:nvSpPr>
+          <p:cNvPr id="23" name="Text 18"/>
+          <p:cNvSpPr/>
+          <p:nvPr/>
+        </p:nvSpPr>
+        <p:spPr>
+          <a:xfrm>
+            <a:off x="13534073" y="5561806"/>
+            <a:ext cx="361950" cy="373380"/>
+          </a:xfrm>
+          <a:prstGeom prst="rect">
+            <a:avLst/>
+          </a:prstGeom>
+          <a:noFill/>
+          <a:ln/>
+        </p:spPr>
+        <p:txBody>
+          <a:bodyPr wrap="square" lIns="25400" tIns="25400" rIns="25400" bIns="25400" rtlCol="0" anchor="t">
+            <a:normAutofit/>
+          </a:bodyPr>
+          <a:lstStyle/>
+          <a:p>
+            <a:pPr algn="l" indent="0" marL="0">
+              <a:buNone/>
+            </a:pPr>
+            <a:r>
+              <a:rPr lang="en-US" sz="2250" dirty="0">
                 <a:solidFill>
                   <a:srgbClr val="212A31"/>
                 </a:solidFill>
@@ -3412,20 +3247,20 @@
               </a:rPr>
               <a:t>→</a:t>
             </a:r>
-            <a:endParaRPr lang="en-US" sz="2700" dirty="0"/>
-          </a:p>
-        </p:txBody>
-      </p:sp>
-      <p:sp>
-        <p:nvSpPr>
-          <p:cNvPr id="27" name="Text 25"/>
-          <p:cNvSpPr/>
-          <p:nvPr/>
-        </p:nvSpPr>
-        <p:spPr>
-          <a:xfrm>
-            <a:off x="14440535" y="6883876"/>
-            <a:ext cx="1032193" cy="533400"/>
+            <a:endParaRPr lang="en-US" sz="2250" dirty="0"/>
+          </a:p>
+        </p:txBody>
+      </p:sp>
+      <p:sp>
+        <p:nvSpPr>
+          <p:cNvPr id="24" name="Text 19"/>
+          <p:cNvSpPr/>
+          <p:nvPr/>
+        </p:nvSpPr>
+        <p:spPr>
+          <a:xfrm>
+            <a:off x="13972223" y="5519896"/>
+            <a:ext cx="885190" cy="457200"/>
           </a:xfrm>
           <a:prstGeom prst="rect">
             <a:avLst/>
@@ -3446,7 +3281,7 @@
               <a:buNone/>
             </a:pPr>
             <a:r>
-              <a:rPr lang="en-US" sz="3900" b="1" dirty="0">
+              <a:rPr lang="en-US" sz="3300" b="1" dirty="0">
                 <a:solidFill>
                   <a:srgbClr val="F77F00"/>
                 </a:solidFill>
@@ -3456,20 +3291,20 @@
               </a:rPr>
               <a:t>FAIL</a:t>
             </a:r>
-            <a:endParaRPr lang="en-US" sz="3900" dirty="0"/>
-          </a:p>
-        </p:txBody>
-      </p:sp>
-      <p:sp>
-        <p:nvSpPr>
-          <p:cNvPr id="28" name="Text 26"/>
-          <p:cNvSpPr/>
-          <p:nvPr/>
-        </p:nvSpPr>
-        <p:spPr>
-          <a:xfrm>
-            <a:off x="12529820" y="7474426"/>
-            <a:ext cx="4588815" cy="312420"/>
+            <a:endParaRPr lang="en-US" sz="3300" dirty="0"/>
+          </a:p>
+        </p:txBody>
+      </p:sp>
+      <p:sp>
+        <p:nvSpPr>
+          <p:cNvPr id="25" name="Text 20"/>
+          <p:cNvSpPr/>
+          <p:nvPr/>
+        </p:nvSpPr>
+        <p:spPr>
+          <a:xfrm>
+            <a:off x="12377420" y="6015196"/>
+            <a:ext cx="4824273" cy="312420"/>
           </a:xfrm>
           <a:prstGeom prst="rect">
             <a:avLst/>
@@ -3509,7 +3344,7 @@
                 <a:ea typeface="Arial" pitchFamily="34" charset="-122"/>
                 <a:cs typeface="Arial" pitchFamily="34" charset="-120"/>
               </a:rPr>
-              <a:t>61.4%</a:t>
+              <a:t>99.37%</a:t>
             </a:r>
             <a:endParaRPr lang="en-US" sz="1680" dirty="0"/>
           </a:p>
@@ -3517,14 +3352,14 @@
       </p:sp>
       <p:sp>
         <p:nvSpPr>
-          <p:cNvPr id="29" name="Text 27"/>
-          <p:cNvSpPr/>
-          <p:nvPr/>
-        </p:nvSpPr>
-        <p:spPr>
-          <a:xfrm>
-            <a:off x="12529820" y="7824946"/>
-            <a:ext cx="4588815" cy="815340"/>
+          <p:cNvPr id="26" name="Text 21"/>
+          <p:cNvSpPr/>
+          <p:nvPr/>
+        </p:nvSpPr>
+        <p:spPr>
+          <a:xfrm>
+            <a:off x="12377420" y="6346666"/>
+            <a:ext cx="4824273" cy="556260"/>
           </a:xfrm>
           <a:prstGeom prst="rect">
             <a:avLst/>
@@ -3550,7 +3385,7 @@
                 <a:ea typeface="Arial" pitchFamily="34" charset="-122"/>
                 <a:cs typeface="Arial" pitchFamily="34" charset="-120"/>
               </a:rPr>
-              <a:t>Model incorrectly flagged defective - unclear wiring detected as improper breadboard design</a:t>
+              <a:t>Unclear wiring detected as improper breadboard design</a:t>
             </a:r>
             <a:endParaRPr lang="en-US" sz="1800" dirty="0"/>
           </a:p>
@@ -3558,13 +3393,13 @@
       </p:sp>
       <p:sp>
         <p:nvSpPr>
-          <p:cNvPr id="30" name="Shape 28"/>
-          <p:cNvSpPr/>
-          <p:nvPr/>
-        </p:nvSpPr>
-        <p:spPr>
-          <a:xfrm>
-            <a:off x="952500" y="9143206"/>
+          <p:cNvPr id="27" name="Shape 22"/>
+          <p:cNvSpPr/>
+          <p:nvPr/>
+        </p:nvSpPr>
+        <p:spPr>
+          <a:xfrm>
+            <a:off x="952500" y="8437245"/>
             <a:ext cx="16383000" cy="1087755"/>
           </a:xfrm>
           <a:prstGeom prst="roundRect">
@@ -3585,13 +3420,13 @@
       </p:sp>
       <p:sp>
         <p:nvSpPr>
-          <p:cNvPr id="31" name="Text 29"/>
-          <p:cNvSpPr/>
-          <p:nvPr/>
-        </p:nvSpPr>
-        <p:spPr>
-          <a:xfrm>
-            <a:off x="1303020" y="9557544"/>
+          <p:cNvPr id="28" name="Text 23"/>
+          <p:cNvSpPr/>
+          <p:nvPr/>
+        </p:nvSpPr>
+        <p:spPr>
+          <a:xfrm>
+            <a:off x="1303020" y="8851582"/>
             <a:ext cx="2356009" cy="297180"/>
           </a:xfrm>
           <a:prstGeom prst="rect">
@@ -3626,13 +3461,13 @@
       </p:sp>
       <p:sp>
         <p:nvSpPr>
-          <p:cNvPr id="32" name="Shape 30"/>
-          <p:cNvSpPr/>
-          <p:nvPr/>
-        </p:nvSpPr>
-        <p:spPr>
-          <a:xfrm>
-            <a:off x="3887629" y="9534684"/>
+          <p:cNvPr id="29" name="Shape 24"/>
+          <p:cNvSpPr/>
+          <p:nvPr/>
+        </p:nvSpPr>
+        <p:spPr>
+          <a:xfrm>
+            <a:off x="3887629" y="8828723"/>
             <a:ext cx="9525" cy="304800"/>
           </a:xfrm>
           <a:prstGeom prst="rect">
@@ -3646,13 +3481,13 @@
       </p:sp>
       <p:sp>
         <p:nvSpPr>
-          <p:cNvPr id="33" name="Text 31"/>
-          <p:cNvSpPr/>
-          <p:nvPr/>
-        </p:nvSpPr>
-        <p:spPr>
-          <a:xfrm>
-            <a:off x="4201954" y="9341326"/>
+          <p:cNvPr id="30" name="Text 25"/>
+          <p:cNvSpPr/>
+          <p:nvPr/>
+        </p:nvSpPr>
+        <p:spPr>
+          <a:xfrm>
+            <a:off x="4201954" y="8635365"/>
             <a:ext cx="13166518" cy="729615"/>
           </a:xfrm>
           <a:prstGeom prst="rect">

</xml_diff>

<commit_message>
Updated Technical Presentation pdf and pptx
- Final touches
</commit_message>
<xml_diff>
--- a/PDE4444_Technical_Presentation.pptx
+++ b/PDE4444_Technical_Presentation.pptx
@@ -1821,7 +1821,7 @@
         </p:nvSpPr>
         <p:spPr>
           <a:xfrm>
-            <a:off x="1333500" y="1702276"/>
+            <a:off x="1333500" y="1443196"/>
             <a:ext cx="6031706" cy="426720"/>
           </a:xfrm>
           <a:prstGeom prst="roundRect">
@@ -1848,7 +1848,7 @@
         </p:nvSpPr>
         <p:spPr>
           <a:xfrm>
-            <a:off x="1512570" y="1767046"/>
+            <a:off x="1512570" y="1507966"/>
             <a:ext cx="5854517" cy="335280"/>
           </a:xfrm>
           <a:prstGeom prst="rect">
@@ -1889,7 +1889,7 @@
         </p:nvSpPr>
         <p:spPr>
           <a:xfrm>
-            <a:off x="1333500" y="2471896"/>
+            <a:off x="1333500" y="2212816"/>
             <a:ext cx="9810750" cy="2630329"/>
           </a:xfrm>
           <a:prstGeom prst="rect">
@@ -1967,7 +1967,7 @@
         </p:nvSpPr>
         <p:spPr>
           <a:xfrm>
-            <a:off x="1333500" y="5407025"/>
+            <a:off x="1333500" y="5147945"/>
             <a:ext cx="6867525" cy="1409700"/>
           </a:xfrm>
           <a:prstGeom prst="rect">
@@ -2011,8 +2011,8 @@
         </p:nvSpPr>
         <p:spPr>
           <a:xfrm>
-            <a:off x="1333500" y="7312025"/>
-            <a:ext cx="3145490" cy="297180"/>
+            <a:off x="1333500" y="7152005"/>
+            <a:ext cx="1961039" cy="297180"/>
           </a:xfrm>
           <a:prstGeom prst="rect">
             <a:avLst/>
@@ -2038,7 +2038,7 @@
                 <a:ea typeface="Arial" pitchFamily="34" charset="-122"/>
                 <a:cs typeface="Arial" pitchFamily="34" charset="-120"/>
               </a:rPr>
-              <a:t>BEST RESULT</a:t>
+              <a:t>AUTHORS</a:t>
             </a:r>
             <a:endParaRPr lang="en-US" sz="1800" dirty="0"/>
           </a:p>
@@ -2052,36 +2052,50 @@
         </p:nvSpPr>
         <p:spPr>
           <a:xfrm>
-            <a:off x="1333500" y="7628255"/>
-            <a:ext cx="3145490" cy="571500"/>
-          </a:xfrm>
-          <a:prstGeom prst="rect">
-            <a:avLst/>
-          </a:prstGeom>
-          <a:noFill/>
-          <a:ln/>
-        </p:spPr>
-        <p:txBody>
-          <a:bodyPr wrap="square" lIns="25400" tIns="25400" rIns="25400" bIns="25400" rtlCol="0" anchor="t">
-            <a:normAutofit/>
-          </a:bodyPr>
-          <a:lstStyle/>
-          <a:p>
-            <a:pPr algn="l" indent="0" marL="0">
-              <a:buNone/>
-            </a:pPr>
-            <a:r>
-              <a:rPr lang="en-US" sz="3300" b="1" dirty="0">
-                <a:solidFill>
-                  <a:srgbClr val="009FE6"/>
-                </a:solidFill>
-                <a:latin typeface="Arial" pitchFamily="34" charset="0"/>
-                <a:ea typeface="Arial" pitchFamily="34" charset="-122"/>
-                <a:cs typeface="Arial" pitchFamily="34" charset="-120"/>
-              </a:rPr>
-              <a:t>93.75%</a:t>
-            </a:r>
-            <a:endParaRPr lang="en-US" sz="3300" dirty="0"/>
+            <a:off x="1333500" y="7468235"/>
+            <a:ext cx="1961039" cy="586740"/>
+          </a:xfrm>
+          <a:prstGeom prst="rect">
+            <a:avLst/>
+          </a:prstGeom>
+          <a:noFill/>
+          <a:ln/>
+        </p:spPr>
+        <p:txBody>
+          <a:bodyPr wrap="square" lIns="25400" tIns="25400" rIns="25400" bIns="25400" rtlCol="0" anchor="t">
+            <a:normAutofit/>
+          </a:bodyPr>
+          <a:lstStyle/>
+          <a:p>
+            <a:pPr algn="l" indent="0" marL="0">
+              <a:buNone/>
+            </a:pPr>
+            <a:r>
+              <a:rPr lang="en-US" sz="1680" b="1" dirty="0">
+                <a:solidFill>
+                  <a:srgbClr val="E8ECEF"/>
+                </a:solidFill>
+                <a:latin typeface="Arial" pitchFamily="34" charset="0"/>
+                <a:ea typeface="Arial" pitchFamily="34" charset="-122"/>
+                <a:cs typeface="Arial" pitchFamily="34" charset="-120"/>
+              </a:rPr>
+              <a:t>Aman Mishra </a:t>
+            </a:r>
+            <a:pPr algn="l" indent="0" marL="0">
+              <a:buNone/>
+            </a:pPr>
+            <a:r>
+              <a:rPr lang="en-US" sz="1680" dirty="0">
+                <a:solidFill>
+                  <a:srgbClr val="80878D"/>
+                </a:solidFill>
+                <a:latin typeface="Arial" pitchFamily="34" charset="0"/>
+                <a:ea typeface="Arial" pitchFamily="34" charset="-122"/>
+                <a:cs typeface="Arial" pitchFamily="34" charset="-120"/>
+              </a:rPr>
+              <a:t>M00983641</a:t>
+            </a:r>
+            <a:endParaRPr lang="en-US" sz="1680" dirty="0"/>
           </a:p>
         </p:txBody>
       </p:sp>
@@ -2093,26 +2107,40 @@
         </p:nvSpPr>
         <p:spPr>
           <a:xfrm>
-            <a:off x="1333500" y="8161655"/>
-            <a:ext cx="3145490" cy="556260"/>
-          </a:xfrm>
-          <a:prstGeom prst="rect">
-            <a:avLst/>
-          </a:prstGeom>
-          <a:noFill/>
-          <a:ln/>
-        </p:spPr>
-        <p:txBody>
-          <a:bodyPr wrap="square" lIns="25400" tIns="25400" rIns="25400" bIns="25400" rtlCol="0" anchor="t">
-            <a:normAutofit/>
-          </a:bodyPr>
-          <a:lstStyle/>
-          <a:p>
-            <a:pPr algn="l" indent="0" marL="0">
-              <a:buNone/>
-            </a:pPr>
-            <a:r>
-              <a:rPr lang="en-US" sz="1800" dirty="0">
+            <a:off x="1333500" y="8016875"/>
+            <a:ext cx="1961039" cy="861060"/>
+          </a:xfrm>
+          <a:prstGeom prst="rect">
+            <a:avLst/>
+          </a:prstGeom>
+          <a:noFill/>
+          <a:ln/>
+        </p:spPr>
+        <p:txBody>
+          <a:bodyPr wrap="square" lIns="25400" tIns="25400" rIns="25400" bIns="25400" rtlCol="0" anchor="t">
+            <a:normAutofit/>
+          </a:bodyPr>
+          <a:lstStyle/>
+          <a:p>
+            <a:pPr algn="l" indent="0" marL="0">
+              <a:buNone/>
+            </a:pPr>
+            <a:r>
+              <a:rPr lang="en-US" sz="1680" b="1" dirty="0">
+                <a:solidFill>
+                  <a:srgbClr val="E8ECEF"/>
+                </a:solidFill>
+                <a:latin typeface="Arial" pitchFamily="34" charset="0"/>
+                <a:ea typeface="Arial" pitchFamily="34" charset="-122"/>
+                <a:cs typeface="Arial" pitchFamily="34" charset="-120"/>
+              </a:rPr>
+              <a:t>Faseeh Mohammed </a:t>
+            </a:r>
+            <a:pPr algn="l" indent="0" marL="0">
+              <a:buNone/>
+            </a:pPr>
+            <a:r>
+              <a:rPr lang="en-US" sz="1680" dirty="0">
                 <a:solidFill>
                   <a:srgbClr val="80878D"/>
                 </a:solidFill>
@@ -2120,9 +2148,9 @@
                 <a:ea typeface="Arial" pitchFamily="34" charset="-122"/>
                 <a:cs typeface="Arial" pitchFamily="34" charset="-120"/>
               </a:rPr>
-              <a:t>CNN Tuned Validation Accuracy</a:t>
-            </a:r>
-            <a:endParaRPr lang="en-US" sz="1800" dirty="0"/>
+              <a:t>M01088120</a:t>
+            </a:r>
+            <a:endParaRPr lang="en-US" sz="1680" dirty="0"/>
           </a:p>
         </p:txBody>
       </p:sp>
@@ -2134,7 +2162,7 @@
         </p:nvSpPr>
         <p:spPr>
           <a:xfrm>
-            <a:off x="4844574" y="7710170"/>
+            <a:off x="3675539" y="7710170"/>
             <a:ext cx="9525" cy="571500"/>
           </a:xfrm>
           <a:prstGeom prst="rect">
@@ -2154,8 +2182,8 @@
         </p:nvSpPr>
         <p:spPr>
           <a:xfrm>
-            <a:off x="5310664" y="7312025"/>
-            <a:ext cx="2846262" cy="297180"/>
+            <a:off x="4138454" y="7182485"/>
+            <a:ext cx="2016919" cy="297180"/>
           </a:xfrm>
           <a:prstGeom prst="rect">
             <a:avLst/>
@@ -2181,7 +2209,7 @@
                 <a:ea typeface="Arial" pitchFamily="34" charset="-122"/>
                 <a:cs typeface="Arial" pitchFamily="34" charset="-120"/>
               </a:rPr>
-              <a:t>MODELS EVALUATED</a:t>
+              <a:t>BEST RESULT</a:t>
             </a:r>
             <a:endParaRPr lang="en-US" sz="1800" dirty="0"/>
           </a:p>
@@ -2195,8 +2223,8 @@
         </p:nvSpPr>
         <p:spPr>
           <a:xfrm>
-            <a:off x="5310664" y="7628255"/>
-            <a:ext cx="2846262" cy="571500"/>
+            <a:off x="4138454" y="7498715"/>
+            <a:ext cx="2016919" cy="571500"/>
           </a:xfrm>
           <a:prstGeom prst="rect">
             <a:avLst/>
@@ -2216,13 +2244,13 @@
             <a:r>
               <a:rPr lang="en-US" sz="3300" b="1" dirty="0">
                 <a:solidFill>
-                  <a:srgbClr val="6684FB"/>
-                </a:solidFill>
-                <a:latin typeface="Arial" pitchFamily="34" charset="0"/>
-                <a:ea typeface="Arial" pitchFamily="34" charset="-122"/>
-                <a:cs typeface="Arial" pitchFamily="34" charset="-120"/>
-              </a:rPr>
-              <a:t>9</a:t>
+                  <a:srgbClr val="009FE6"/>
+                </a:solidFill>
+                <a:latin typeface="Arial" pitchFamily="34" charset="0"/>
+                <a:ea typeface="Arial" pitchFamily="34" charset="-122"/>
+                <a:cs typeface="Arial" pitchFamily="34" charset="-120"/>
+              </a:rPr>
+              <a:t>93.75%</a:t>
             </a:r>
             <a:endParaRPr lang="en-US" sz="3300" dirty="0"/>
           </a:p>
@@ -2236,8 +2264,8 @@
         </p:nvSpPr>
         <p:spPr>
           <a:xfrm>
-            <a:off x="5310664" y="8161655"/>
-            <a:ext cx="2846262" cy="556260"/>
+            <a:off x="4138454" y="8032115"/>
+            <a:ext cx="2016919" cy="815340"/>
           </a:xfrm>
           <a:prstGeom prst="rect">
             <a:avLst/>
@@ -2263,7 +2291,7 @@
                 <a:ea typeface="Arial" pitchFamily="34" charset="-122"/>
                 <a:cs typeface="Arial" pitchFamily="34" charset="-120"/>
               </a:rPr>
-              <a:t>CNN + 6 Classical + Variants</a:t>
+              <a:t>CNN Tuned Validation Accuracy</a:t>
             </a:r>
             <a:endParaRPr lang="en-US" sz="1800" dirty="0"/>
           </a:p>
@@ -2277,7 +2305,7 @@
         </p:nvSpPr>
         <p:spPr>
           <a:xfrm>
-            <a:off x="8531225" y="7710170"/>
+            <a:off x="6536373" y="7710170"/>
             <a:ext cx="9525" cy="571500"/>
           </a:xfrm>
           <a:prstGeom prst="rect">
@@ -2297,8 +2325,8 @@
         </p:nvSpPr>
         <p:spPr>
           <a:xfrm>
-            <a:off x="8997315" y="7312025"/>
-            <a:ext cx="1937385" cy="297180"/>
+            <a:off x="6999287" y="7052945"/>
+            <a:ext cx="1832451" cy="556260"/>
           </a:xfrm>
           <a:prstGeom prst="rect">
             <a:avLst/>
@@ -2324,6 +2352,149 @@
                 <a:ea typeface="Arial" pitchFamily="34" charset="-122"/>
                 <a:cs typeface="Arial" pitchFamily="34" charset="-120"/>
               </a:rPr>
+              <a:t>MODELS EVALUATED</a:t>
+            </a:r>
+            <a:endParaRPr lang="en-US" sz="1800" dirty="0"/>
+          </a:p>
+        </p:txBody>
+      </p:sp>
+      <p:sp>
+        <p:nvSpPr>
+          <p:cNvPr id="17" name="Text 15"/>
+          <p:cNvSpPr/>
+          <p:nvPr/>
+        </p:nvSpPr>
+        <p:spPr>
+          <a:xfrm>
+            <a:off x="6999287" y="7628255"/>
+            <a:ext cx="1832451" cy="571500"/>
+          </a:xfrm>
+          <a:prstGeom prst="rect">
+            <a:avLst/>
+          </a:prstGeom>
+          <a:noFill/>
+          <a:ln/>
+        </p:spPr>
+        <p:txBody>
+          <a:bodyPr wrap="square" lIns="25400" tIns="25400" rIns="25400" bIns="25400" rtlCol="0" anchor="t">
+            <a:normAutofit/>
+          </a:bodyPr>
+          <a:lstStyle/>
+          <a:p>
+            <a:pPr algn="l" indent="0" marL="0">
+              <a:buNone/>
+            </a:pPr>
+            <a:r>
+              <a:rPr lang="en-US" sz="3300" b="1" dirty="0">
+                <a:solidFill>
+                  <a:srgbClr val="6684FB"/>
+                </a:solidFill>
+                <a:latin typeface="Arial" pitchFamily="34" charset="0"/>
+                <a:ea typeface="Arial" pitchFamily="34" charset="-122"/>
+                <a:cs typeface="Arial" pitchFamily="34" charset="-120"/>
+              </a:rPr>
+              <a:t>9</a:t>
+            </a:r>
+            <a:endParaRPr lang="en-US" sz="3300" dirty="0"/>
+          </a:p>
+        </p:txBody>
+      </p:sp>
+      <p:sp>
+        <p:nvSpPr>
+          <p:cNvPr id="18" name="Text 16"/>
+          <p:cNvSpPr/>
+          <p:nvPr/>
+        </p:nvSpPr>
+        <p:spPr>
+          <a:xfrm>
+            <a:off x="6999287" y="8161655"/>
+            <a:ext cx="1832451" cy="815340"/>
+          </a:xfrm>
+          <a:prstGeom prst="rect">
+            <a:avLst/>
+          </a:prstGeom>
+          <a:noFill/>
+          <a:ln/>
+        </p:spPr>
+        <p:txBody>
+          <a:bodyPr wrap="square" lIns="25400" tIns="25400" rIns="25400" bIns="25400" rtlCol="0" anchor="t">
+            <a:normAutofit/>
+          </a:bodyPr>
+          <a:lstStyle/>
+          <a:p>
+            <a:pPr algn="l" indent="0" marL="0">
+              <a:buNone/>
+            </a:pPr>
+            <a:r>
+              <a:rPr lang="en-US" sz="1800" dirty="0">
+                <a:solidFill>
+                  <a:srgbClr val="80878D"/>
+                </a:solidFill>
+                <a:latin typeface="Arial" pitchFamily="34" charset="0"/>
+                <a:ea typeface="Arial" pitchFamily="34" charset="-122"/>
+                <a:cs typeface="Arial" pitchFamily="34" charset="-120"/>
+              </a:rPr>
+              <a:t>CNN + 6 Classical + Variants</a:t>
+            </a:r>
+            <a:endParaRPr lang="en-US" sz="1800" dirty="0"/>
+          </a:p>
+        </p:txBody>
+      </p:sp>
+      <p:sp>
+        <p:nvSpPr>
+          <p:cNvPr id="19" name="Shape 17"/>
+          <p:cNvSpPr/>
+          <p:nvPr/>
+        </p:nvSpPr>
+        <p:spPr>
+          <a:xfrm>
+            <a:off x="9212739" y="7710170"/>
+            <a:ext cx="9525" cy="571500"/>
+          </a:xfrm>
+          <a:prstGeom prst="rect">
+            <a:avLst/>
+          </a:prstGeom>
+          <a:solidFill>
+            <a:srgbClr val="212A31"/>
+          </a:solidFill>
+          <a:ln/>
+        </p:spPr>
+      </p:sp>
+      <p:sp>
+        <p:nvSpPr>
+          <p:cNvPr id="20" name="Text 18"/>
+          <p:cNvSpPr/>
+          <p:nvPr/>
+        </p:nvSpPr>
+        <p:spPr>
+          <a:xfrm>
+            <a:off x="9675654" y="7312025"/>
+            <a:ext cx="1259046" cy="297180"/>
+          </a:xfrm>
+          <a:prstGeom prst="rect">
+            <a:avLst/>
+          </a:prstGeom>
+          <a:noFill/>
+          <a:ln/>
+        </p:spPr>
+        <p:txBody>
+          <a:bodyPr wrap="square" lIns="25400" tIns="25400" rIns="25400" bIns="25400" rtlCol="0" anchor="t">
+            <a:normAutofit/>
+          </a:bodyPr>
+          <a:lstStyle/>
+          <a:p>
+            <a:pPr algn="l" indent="0" marL="0">
+              <a:buNone/>
+            </a:pPr>
+            <a:r>
+              <a:rPr lang="en-US" sz="1800" spc="180" kern="0" dirty="0">
+                <a:solidFill>
+                  <a:srgbClr val="80878D"/>
+                </a:solidFill>
+                <a:latin typeface="Arial" pitchFamily="34" charset="0"/>
+                <a:ea typeface="Arial" pitchFamily="34" charset="-122"/>
+                <a:cs typeface="Arial" pitchFamily="34" charset="-120"/>
+              </a:rPr>
               <a:t>DATASET</a:t>
             </a:r>
             <a:endParaRPr lang="en-US" sz="1800" dirty="0"/>
@@ -2332,14 +2503,14 @@
       </p:sp>
       <p:sp>
         <p:nvSpPr>
-          <p:cNvPr id="17" name="Text 15"/>
-          <p:cNvSpPr/>
-          <p:nvPr/>
-        </p:nvSpPr>
-        <p:spPr>
-          <a:xfrm>
-            <a:off x="8997315" y="7628255"/>
-            <a:ext cx="1937385" cy="571500"/>
+          <p:cNvPr id="21" name="Text 19"/>
+          <p:cNvSpPr/>
+          <p:nvPr/>
+        </p:nvSpPr>
+        <p:spPr>
+          <a:xfrm>
+            <a:off x="9675654" y="7628255"/>
+            <a:ext cx="1259046" cy="571500"/>
           </a:xfrm>
           <a:prstGeom prst="rect">
             <a:avLst/>
@@ -2373,14 +2544,14 @@
       </p:sp>
       <p:sp>
         <p:nvSpPr>
-          <p:cNvPr id="18" name="Text 16"/>
-          <p:cNvSpPr/>
-          <p:nvPr/>
-        </p:nvSpPr>
-        <p:spPr>
-          <a:xfrm>
-            <a:off x="8997315" y="8161655"/>
-            <a:ext cx="1937385" cy="556260"/>
+          <p:cNvPr id="22" name="Text 20"/>
+          <p:cNvSpPr/>
+          <p:nvPr/>
+        </p:nvSpPr>
+        <p:spPr>
+          <a:xfrm>
+            <a:off x="9675654" y="8161655"/>
+            <a:ext cx="1259046" cy="556260"/>
           </a:xfrm>
           <a:prstGeom prst="rect">
             <a:avLst/>

</xml_diff>